<commit_message>
Frame the module figures and group the bottleneck
The published Figs. 4 and 5 sit inside an outer rectangle, and Fig. 4 groups its
squeeze, activation and expand under a Bottle Neck sub-frame. The replacements had
neither, so they read as loose blocks on a page rather than as one figure.

Each now carries a frame computed from what is actually drawn, including routed
waypoints and sub-frames, with the title anchored inside it rather than at a fixed
page coordinate. Padding could previously push the frame past the origin, so the
whole figure is shifted to start at a positive corner and the page is sized to the
frame instead of being set by hand.

Co-Authored-By: Claude Opus 5 (1M context) <noreply@anthropic.com>
</commit_message>
<xml_diff>
--- a/ablation/figures/channel-attention.pptx
+++ b/ablation/figures/channel-attention.pptx
@@ -3088,78 +3088,110 @@
         <p:nvPr/>
       </p:nvGrpSpPr>
       <p:grpSpPr/>
-      <p:cxnSp>
-        <p:nvCxnSpPr>
-          <p:cNvPr id="2" name="Connector 1"/>
-          <p:cNvCxnSpPr/>
+      <p:sp>
+        <p:nvSpPr>
+          <p:cNvPr id="2" name="Rounded Rectangle 1"/>
+          <p:cNvSpPr/>
           <p:nvPr/>
-        </p:nvCxnSpPr>
+        </p:nvSpPr>
         <p:spPr>
           <a:xfrm>
-            <a:off x="1585401" y="3419832"/>
-            <a:ext cx="366702" cy="0"/>
+            <a:off x="228600" y="2310170"/>
+            <a:ext cx="11734495" cy="2237658"/>
           </a:xfrm>
-          <a:prstGeom prst="line">
-            <a:avLst/>
+          <a:prstGeom prst="roundRect">
+            <a:avLst>
+              <a:gd name="adj" fmla="val 16000"/>
+            </a:avLst>
           </a:prstGeom>
-          <a:ln w="21590">
+          <a:solidFill>
+            <a:srgbClr val="FDFDFE"/>
+          </a:solidFill>
+          <a:ln w="17780">
             <a:solidFill>
-              <a:srgbClr val="25384B"/>
+              <a:srgbClr val="7E93A6"/>
             </a:solidFill>
-            <a:tailEnd type="triangle" w="med" len="med"/>
           </a:ln>
+          <a:effectLst/>
         </p:spPr>
         <p:style>
-          <a:lnRef idx="2">
+          <a:lnRef idx="1">
             <a:schemeClr val="accent1"/>
           </a:lnRef>
-          <a:fillRef idx="0">
+          <a:fillRef idx="3">
             <a:schemeClr val="accent1"/>
           </a:fillRef>
-          <a:effectRef idx="1">
+          <a:effectRef idx="2">
             <a:schemeClr val="accent1"/>
           </a:effectRef>
           <a:fontRef idx="minor">
-            <a:schemeClr val="tx1"/>
+            <a:schemeClr val="lt1"/>
           </a:fontRef>
         </p:style>
-      </p:cxnSp>
-      <p:cxnSp>
-        <p:nvCxnSpPr>
-          <p:cNvPr id="3" name="Connector 2"/>
-          <p:cNvCxnSpPr/>
+        <p:txBody>
+          <a:bodyPr rtlCol="0" anchor="ctr" wrap="square" lIns="27000" rIns="27000" tIns="0" bIns="0"/>
+          <a:lstStyle/>
+          <a:p>
+            <a:pPr algn="ctr"/>
+          </a:p>
+        </p:txBody>
+      </p:sp>
+      <p:sp>
+        <p:nvSpPr>
+          <p:cNvPr id="3" name="Rounded Rectangle 2"/>
+          <p:cNvSpPr/>
           <p:nvPr/>
-        </p:nvCxnSpPr>
+        </p:nvSpPr>
         <p:spPr>
           <a:xfrm>
-            <a:off x="3308904" y="3419832"/>
-            <a:ext cx="366703" cy="0"/>
+            <a:off x="3629136" y="2838751"/>
+            <a:ext cx="4616272" cy="828110"/>
           </a:xfrm>
-          <a:prstGeom prst="line">
-            <a:avLst/>
+          <a:prstGeom prst="roundRect">
+            <a:avLst>
+              <a:gd name="adj" fmla="val 16000"/>
+            </a:avLst>
           </a:prstGeom>
-          <a:ln w="21590">
+          <a:noFill/>
+          <a:ln w="13970">
             <a:solidFill>
-              <a:srgbClr val="25384B"/>
+              <a:srgbClr val="A2B2C0"/>
             </a:solidFill>
-            <a:tailEnd type="triangle" w="med" len="med"/>
+            <a:prstDash val="dash"/>
           </a:ln>
+          <a:effectLst/>
         </p:spPr>
         <p:style>
-          <a:lnRef idx="2">
+          <a:lnRef idx="1">
             <a:schemeClr val="accent1"/>
           </a:lnRef>
-          <a:fillRef idx="0">
+          <a:fillRef idx="3">
             <a:schemeClr val="accent1"/>
           </a:fillRef>
-          <a:effectRef idx="1">
+          <a:effectRef idx="2">
             <a:schemeClr val="accent1"/>
           </a:effectRef>
           <a:fontRef idx="minor">
-            <a:schemeClr val="tx1"/>
+            <a:schemeClr val="lt1"/>
           </a:fontRef>
         </p:style>
-      </p:cxnSp>
+        <p:txBody>
+          <a:bodyPr rtlCol="0" anchor="ctr" wrap="square" lIns="27000" rIns="27000" tIns="0" bIns="0"/>
+          <a:lstStyle/>
+          <a:p>
+            <a:pPr algn="ctr"/>
+            <a:r>
+              <a:rPr sz="825" b="0" i="1">
+                <a:solidFill>
+                  <a:srgbClr val="5F7488"/>
+                </a:solidFill>
+                <a:latin typeface="Helvetica"/>
+              </a:rPr>
+              <a:t>Bottleneck</a:t>
+            </a:r>
+          </a:p>
+        </p:txBody>
+      </p:sp>
       <p:cxnSp>
         <p:nvCxnSpPr>
           <p:cNvPr id="4" name="Connector 3"/>
@@ -3168,8 +3200,8 @@
         </p:nvCxnSpPr>
         <p:spPr>
           <a:xfrm>
-            <a:off x="5124084" y="3419832"/>
-            <a:ext cx="366703" cy="0"/>
+            <a:off x="1761484" y="3252806"/>
+            <a:ext cx="352387" cy="0"/>
           </a:xfrm>
           <a:prstGeom prst="line">
             <a:avLst/>
@@ -3204,8 +3236,8 @@
         </p:nvCxnSpPr>
         <p:spPr>
           <a:xfrm>
-            <a:off x="6370874" y="3419832"/>
-            <a:ext cx="366703" cy="0"/>
+            <a:off x="3417704" y="3252806"/>
+            <a:ext cx="352387" cy="0"/>
           </a:xfrm>
           <a:prstGeom prst="line">
             <a:avLst/>
@@ -3240,8 +3272,8 @@
         </p:nvCxnSpPr>
         <p:spPr>
           <a:xfrm>
-            <a:off x="8186054" y="3419832"/>
-            <a:ext cx="366703" cy="0"/>
+            <a:off x="5162021" y="3252806"/>
+            <a:ext cx="352387" cy="0"/>
           </a:xfrm>
           <a:prstGeom prst="line">
             <a:avLst/>
@@ -3276,8 +3308,8 @@
         </p:nvCxnSpPr>
         <p:spPr>
           <a:xfrm>
-            <a:off x="9744542" y="3419832"/>
-            <a:ext cx="366703" cy="0"/>
+            <a:off x="6360138" y="3252806"/>
+            <a:ext cx="352387" cy="0"/>
           </a:xfrm>
           <a:prstGeom prst="line">
             <a:avLst/>
@@ -3312,8 +3344,8 @@
         </p:nvCxnSpPr>
         <p:spPr>
           <a:xfrm>
-            <a:off x="10532953" y="3419832"/>
-            <a:ext cx="366703" cy="0"/>
+            <a:off x="8104454" y="3252806"/>
+            <a:ext cx="352388" cy="0"/>
           </a:xfrm>
           <a:prstGeom prst="line">
             <a:avLst/>
@@ -3348,16 +3380,17 @@
         </p:nvCxnSpPr>
         <p:spPr>
           <a:xfrm>
-            <a:off x="907000" y="3704027"/>
-            <a:ext cx="0" cy="825081"/>
+            <a:off x="9602100" y="3252806"/>
+            <a:ext cx="352387" cy="0"/>
           </a:xfrm>
           <a:prstGeom prst="line">
             <a:avLst/>
           </a:prstGeom>
-          <a:ln w="16510">
+          <a:ln w="21590">
             <a:solidFill>
-              <a:srgbClr val="6E8399"/>
+              <a:srgbClr val="25384B"/>
             </a:solidFill>
+            <a:tailEnd type="triangle" w="med" len="med"/>
           </a:ln>
         </p:spPr>
         <p:style>
@@ -3383,16 +3416,17 @@
         </p:nvCxnSpPr>
         <p:spPr>
           <a:xfrm>
-            <a:off x="907000" y="4529108"/>
-            <a:ext cx="9415099" cy="0"/>
+            <a:off x="10359733" y="3252806"/>
+            <a:ext cx="352387" cy="0"/>
           </a:xfrm>
           <a:prstGeom prst="line">
             <a:avLst/>
           </a:prstGeom>
-          <a:ln w="16510">
+          <a:ln w="21590">
             <a:solidFill>
-              <a:srgbClr val="6E8399"/>
+              <a:srgbClr val="25384B"/>
             </a:solidFill>
+            <a:tailEnd type="triangle" w="med" len="med"/>
           </a:ln>
         </p:spPr>
         <p:style>
@@ -3417,9 +3451,79 @@
           <p:nvPr/>
         </p:nvCxnSpPr>
         <p:spPr>
+          <a:xfrm>
+            <a:off x="1109568" y="3525906"/>
+            <a:ext cx="0" cy="792871"/>
+          </a:xfrm>
+          <a:prstGeom prst="line">
+            <a:avLst/>
+          </a:prstGeom>
+          <a:ln w="16510">
+            <a:solidFill>
+              <a:srgbClr val="6E8399"/>
+            </a:solidFill>
+          </a:ln>
+        </p:spPr>
+        <p:style>
+          <a:lnRef idx="2">
+            <a:schemeClr val="accent1"/>
+          </a:lnRef>
+          <a:fillRef idx="0">
+            <a:schemeClr val="accent1"/>
+          </a:fillRef>
+          <a:effectRef idx="1">
+            <a:schemeClr val="accent1"/>
+          </a:effectRef>
+          <a:fontRef idx="minor">
+            <a:schemeClr val="tx1"/>
+          </a:fontRef>
+        </p:style>
+      </p:cxnSp>
+      <p:cxnSp>
+        <p:nvCxnSpPr>
+          <p:cNvPr id="12" name="Connector 11"/>
+          <p:cNvCxnSpPr/>
+          <p:nvPr/>
+        </p:nvCxnSpPr>
+        <p:spPr>
+          <a:xfrm>
+            <a:off x="1109568" y="4318777"/>
+            <a:ext cx="9047542" cy="0"/>
+          </a:xfrm>
+          <a:prstGeom prst="line">
+            <a:avLst/>
+          </a:prstGeom>
+          <a:ln w="16510">
+            <a:solidFill>
+              <a:srgbClr val="6E8399"/>
+            </a:solidFill>
+          </a:ln>
+        </p:spPr>
+        <p:style>
+          <a:lnRef idx="2">
+            <a:schemeClr val="accent1"/>
+          </a:lnRef>
+          <a:fillRef idx="0">
+            <a:schemeClr val="accent1"/>
+          </a:fillRef>
+          <a:effectRef idx="1">
+            <a:schemeClr val="accent1"/>
+          </a:effectRef>
+          <a:fontRef idx="minor">
+            <a:schemeClr val="tx1"/>
+          </a:fontRef>
+        </p:style>
+      </p:cxnSp>
+      <p:cxnSp>
+        <p:nvCxnSpPr>
+          <p:cNvPr id="13" name="Connector 12"/>
+          <p:cNvCxnSpPr/>
+          <p:nvPr/>
+        </p:nvCxnSpPr>
+        <p:spPr>
           <a:xfrm flipV="1">
-            <a:off x="10322099" y="3630686"/>
-            <a:ext cx="0" cy="898422"/>
+            <a:off x="10157110" y="3455429"/>
+            <a:ext cx="0" cy="863348"/>
           </a:xfrm>
           <a:prstGeom prst="line">
             <a:avLst/>
@@ -3448,14 +3552,14 @@
       </p:cxnSp>
       <p:sp>
         <p:nvSpPr>
-          <p:cNvPr id="12" name="Rounded Rectangle 11"/>
+          <p:cNvPr id="14" name="Rounded Rectangle 13"/>
           <p:cNvSpPr/>
           <p:nvPr/>
         </p:nvSpPr>
         <p:spPr>
           <a:xfrm>
-            <a:off x="228600" y="3135637"/>
-            <a:ext cx="1356801" cy="568389"/>
+            <a:off x="457651" y="2979706"/>
+            <a:ext cx="1303832" cy="546200"/>
           </a:xfrm>
           <a:prstGeom prst="roundRect">
             <a:avLst>
@@ -3517,14 +3621,14 @@
       </p:sp>
       <p:sp>
         <p:nvSpPr>
-          <p:cNvPr id="13" name="Rounded Rectangle 12"/>
+          <p:cNvPr id="15" name="Rounded Rectangle 14"/>
           <p:cNvSpPr/>
           <p:nvPr/>
         </p:nvSpPr>
         <p:spPr>
           <a:xfrm>
-            <a:off x="1952103" y="3135637"/>
-            <a:ext cx="1356801" cy="568389"/>
+            <a:off x="2113871" y="2979706"/>
+            <a:ext cx="1303832" cy="546200"/>
           </a:xfrm>
           <a:prstGeom prst="roundRect">
             <a:avLst>
@@ -3586,14 +3690,14 @@
       </p:sp>
       <p:sp>
         <p:nvSpPr>
-          <p:cNvPr id="14" name="Rounded Rectangle 13"/>
+          <p:cNvPr id="16" name="Rounded Rectangle 15"/>
           <p:cNvSpPr/>
           <p:nvPr/>
         </p:nvSpPr>
         <p:spPr>
           <a:xfrm>
-            <a:off x="3675607" y="3135637"/>
-            <a:ext cx="1448476" cy="568389"/>
+            <a:off x="3770091" y="2979706"/>
+            <a:ext cx="1391929" cy="546200"/>
           </a:xfrm>
           <a:prstGeom prst="roundRect">
             <a:avLst>
@@ -3655,14 +3759,14 @@
       </p:sp>
       <p:sp>
         <p:nvSpPr>
-          <p:cNvPr id="15" name="Rounded Rectangle 14"/>
+          <p:cNvPr id="17" name="Rounded Rectangle 16"/>
           <p:cNvSpPr/>
           <p:nvPr/>
         </p:nvSpPr>
         <p:spPr>
           <a:xfrm>
-            <a:off x="5490787" y="3135637"/>
-            <a:ext cx="880087" cy="568389"/>
+            <a:off x="5514408" y="2979706"/>
+            <a:ext cx="845729" cy="546200"/>
           </a:xfrm>
           <a:prstGeom prst="roundRect">
             <a:avLst>
@@ -3712,14 +3816,14 @@
       </p:sp>
       <p:sp>
         <p:nvSpPr>
-          <p:cNvPr id="16" name="Rounded Rectangle 15"/>
+          <p:cNvPr id="18" name="Rounded Rectangle 17"/>
           <p:cNvSpPr/>
           <p:nvPr/>
         </p:nvSpPr>
         <p:spPr>
           <a:xfrm>
-            <a:off x="6737577" y="3135637"/>
-            <a:ext cx="1448476" cy="568389"/>
+            <a:off x="6712525" y="2979706"/>
+            <a:ext cx="1391929" cy="546200"/>
           </a:xfrm>
           <a:prstGeom prst="roundRect">
             <a:avLst>
@@ -3781,14 +3885,14 @@
       </p:sp>
       <p:sp>
         <p:nvSpPr>
-          <p:cNvPr id="17" name="Rounded Rectangle 16"/>
+          <p:cNvPr id="19" name="Rounded Rectangle 18"/>
           <p:cNvSpPr/>
           <p:nvPr/>
         </p:nvSpPr>
         <p:spPr>
           <a:xfrm>
-            <a:off x="8552757" y="3135637"/>
-            <a:ext cx="1191784" cy="568389"/>
+            <a:off x="8456842" y="2979706"/>
+            <a:ext cx="1145258" cy="546200"/>
           </a:xfrm>
           <a:prstGeom prst="roundRect">
             <a:avLst>
@@ -3850,14 +3954,14 @@
       </p:sp>
       <p:sp>
         <p:nvSpPr>
-          <p:cNvPr id="18" name="Rounded Rectangle 17"/>
+          <p:cNvPr id="20" name="Rounded Rectangle 19"/>
           <p:cNvSpPr/>
           <p:nvPr/>
         </p:nvSpPr>
         <p:spPr>
           <a:xfrm>
-            <a:off x="10111245" y="3208978"/>
-            <a:ext cx="421708" cy="421708"/>
+            <a:off x="9954487" y="3050183"/>
+            <a:ext cx="405245" cy="405245"/>
           </a:xfrm>
           <a:prstGeom prst="roundRect">
             <a:avLst>
@@ -3907,14 +4011,14 @@
       </p:sp>
       <p:sp>
         <p:nvSpPr>
-          <p:cNvPr id="19" name="Rounded Rectangle 18"/>
+          <p:cNvPr id="21" name="Rounded Rectangle 20"/>
           <p:cNvSpPr/>
           <p:nvPr/>
         </p:nvSpPr>
         <p:spPr>
           <a:xfrm>
-            <a:off x="10899656" y="3135637"/>
-            <a:ext cx="1063438" cy="568389"/>
+            <a:off x="10712120" y="2979706"/>
+            <a:ext cx="1021923" cy="546200"/>
           </a:xfrm>
           <a:prstGeom prst="roundRect">
             <a:avLst>
@@ -3976,14 +4080,14 @@
       </p:sp>
       <p:sp>
         <p:nvSpPr>
-          <p:cNvPr id="20" name="Rounded Rectangle 19"/>
+          <p:cNvPr id="22" name="Rounded Rectangle 21"/>
           <p:cNvSpPr/>
           <p:nvPr/>
         </p:nvSpPr>
         <p:spPr>
           <a:xfrm>
-            <a:off x="228600" y="2328891"/>
-            <a:ext cx="5500544" cy="238356"/>
+            <a:off x="404793" y="2415886"/>
+            <a:ext cx="5285808" cy="229051"/>
           </a:xfrm>
           <a:prstGeom prst="roundRect">
             <a:avLst>

</xml_diff>

<commit_message>
Size the edge and sub-frame captions to match the blocks
The Q, K/V, identity and residual captions sat at 10px in a light slate, and the
Bottleneck caption at 11px italic in a lighter one, so the labels that say what a
connection carries were the least legible text in the figure. They now sit at 13px
bold in near-ink, close to the 12px of the block names they sit between, and the
dashed identity paths carry a little more weight so the captions have something to
attach to.

Co-Authored-By: Claude Opus 5 (1M context) <noreply@anthropic.com>
</commit_message>
<xml_diff>
--- a/ablation/figures/channel-attention.pptx
+++ b/ablation/figures/channel-attention.pptx
@@ -3153,9 +3153,9 @@
             </a:avLst>
           </a:prstGeom>
           <a:noFill/>
-          <a:ln w="13970">
+          <a:ln w="15240">
             <a:solidFill>
-              <a:srgbClr val="A2B2C0"/>
+              <a:srgbClr val="8FA3B5"/>
             </a:solidFill>
             <a:prstDash val="dash"/>
           </a:ln>
@@ -3181,9 +3181,9 @@
           <a:p>
             <a:pPr algn="ctr"/>
             <a:r>
-              <a:rPr sz="825" b="0" i="1">
+              <a:rPr sz="975" b="1" i="0">
                 <a:solidFill>
-                  <a:srgbClr val="5F7488"/>
+                  <a:srgbClr val="3D5468"/>
                 </a:solidFill>
                 <a:latin typeface="Helvetica"/>
               </a:rPr>
@@ -3458,9 +3458,9 @@
           <a:prstGeom prst="line">
             <a:avLst/>
           </a:prstGeom>
-          <a:ln w="16510">
+          <a:ln w="19050">
             <a:solidFill>
-              <a:srgbClr val="6E8399"/>
+              <a:srgbClr val="5C748C"/>
             </a:solidFill>
           </a:ln>
         </p:spPr>
@@ -3493,9 +3493,9 @@
           <a:prstGeom prst="line">
             <a:avLst/>
           </a:prstGeom>
-          <a:ln w="16510">
+          <a:ln w="19050">
             <a:solidFill>
-              <a:srgbClr val="6E8399"/>
+              <a:srgbClr val="5C748C"/>
             </a:solidFill>
           </a:ln>
         </p:spPr>
@@ -3528,9 +3528,9 @@
           <a:prstGeom prst="line">
             <a:avLst/>
           </a:prstGeom>
-          <a:ln w="16510">
+          <a:ln w="19050">
             <a:solidFill>
-              <a:srgbClr val="6E8399"/>
+              <a:srgbClr val="5C748C"/>
             </a:solidFill>
             <a:tailEnd type="triangle" w="med" len="med"/>
           </a:ln>

</xml_diff>